<commit_message>
harness: regenerate frontend-design + pptx artifacts with the round-2 prefs/checks
Live --agent run (claude-haiku-4-5) of landing_hero, pricing_cards, pitch_deck
under the corrected preferences. Every new preference now has a clean baseline
(cold_honored=False) AND the warm artifact genuinely honors it: pricing_cards
warm carries the global `border-radius:0 !important` reset (cold does not);
pitch_deck warm is a square 1:1 deck (slide_height=Inches(10); cold is 7.5in tall)
with Consolas on every run; landing_hero warm uses #FF6B00 for the accent.
Regenerated out/metrics.json: 3 skills, 18/18 preferences stuck.

Co-Authored-By: Claude Opus 4.8 (1M context) <noreply@anthropic.com>
</commit_message>
<xml_diff>
--- a/harness/out/pptx/pitch_deck/cold/deck.pptx
+++ b/harness/out/pptx/pitch_deck/cold/deck.pptx
@@ -3117,15 +3117,15 @@
           <a:noFill/>
         </p:spPr>
         <p:txBody>
-          <a:bodyPr wrap="none">
+          <a:bodyPr wrap="square">
             <a:spAutoFit/>
           </a:bodyPr>
           <a:lstStyle/>
           <a:p>
             <a:pPr algn="ctr">
-              <a:defRPr sz="8800" b="1">
+              <a:defRPr sz="7200" b="1">
                 <a:solidFill>
-                  <a:srgbClr val="007896"/>
+                  <a:srgbClr val="009688"/>
                 </a:solidFill>
                 <a:latin typeface="Calibri"/>
               </a:defRPr>
@@ -3145,7 +3145,7 @@
         <p:spPr>
           <a:xfrm>
             <a:off x="457200" y="3840480"/>
-            <a:ext cx="8229600" cy="1371600"/>
+            <a:ext cx="8229600" cy="914400"/>
           </a:xfrm>
           <a:prstGeom prst="rect">
             <a:avLst/>
@@ -3161,7 +3161,7 @@
             <a:pPr algn="ctr">
               <a:defRPr sz="3200">
                 <a:solidFill>
-                  <a:srgbClr val="646464"/>
+                  <a:srgbClr val="1E1E1E"/>
                 </a:solidFill>
                 <a:latin typeface="Calibri"/>
               </a:defRPr>
@@ -3206,8 +3206,8 @@
         </p:nvSpPr>
         <p:spPr>
           <a:xfrm>
-            <a:off x="457200" y="457200"/>
-            <a:ext cx="8229600" cy="914400"/>
+            <a:off x="685800" y="457200"/>
+            <a:ext cx="7772400" cy="914400"/>
           </a:xfrm>
           <a:prstGeom prst="rect">
             <a:avLst/>
@@ -3215,7 +3215,7 @@
           <a:noFill/>
         </p:spPr>
         <p:txBody>
-          <a:bodyPr wrap="none">
+          <a:bodyPr wrap="square">
             <a:spAutoFit/>
           </a:bodyPr>
           <a:lstStyle/>
@@ -3223,7 +3223,7 @@
             <a:pPr>
               <a:defRPr sz="5400" b="1">
                 <a:solidFill>
-                  <a:srgbClr val="282828"/>
+                  <a:srgbClr val="009688"/>
                 </a:solidFill>
                 <a:latin typeface="Calibri"/>
               </a:defRPr>
@@ -3242,8 +3242,8 @@
         </p:nvSpPr>
         <p:spPr>
           <a:xfrm>
-            <a:off x="914400" y="1828800"/>
-            <a:ext cx="7315200" cy="4114800"/>
+            <a:off x="1371600" y="1645920"/>
+            <a:ext cx="7315200" cy="4572000"/>
           </a:xfrm>
           <a:prstGeom prst="rect">
             <a:avLst/>
@@ -3265,13 +3265,13 @@
               </a:spcAft>
               <a:defRPr sz="2800">
                 <a:solidFill>
-                  <a:srgbClr val="282828"/>
+                  <a:srgbClr val="1E1E1E"/>
                 </a:solidFill>
                 <a:latin typeface="Calibri"/>
               </a:defRPr>
             </a:pPr>
             <a:r>
-              <a:t>Large test suites are slow and hard to navigate.</a:t>
+              <a:t>Large suites are slow and opaque</a:t>
             </a:r>
           </a:p>
           <a:p>
@@ -3284,11 +3284,14 @@
               </a:spcAft>
               <a:defRPr sz="2800">
                 <a:solidFill>
-                  <a:srgbClr val="282828"/>
+                  <a:srgbClr val="1E1E1E"/>
                 </a:solidFill>
                 <a:latin typeface="Calibri"/>
               </a:defRPr>
             </a:pPr>
+            <a:r>
+              <a:t>Nobody knows which tests cover which code</a:t>
+            </a:r>
           </a:p>
           <a:p>
             <a:pPr>
@@ -3300,48 +3303,13 @@
               </a:spcAft>
               <a:defRPr sz="2800">
                 <a:solidFill>
-                  <a:srgbClr val="282828"/>
+                  <a:srgbClr val="1E1E1E"/>
                 </a:solidFill>
                 <a:latin typeface="Calibri"/>
               </a:defRPr>
             </a:pPr>
             <a:r>
-              <a:t>Nobody knows which tests cover which code.</a:t>
-            </a:r>
-          </a:p>
-          <a:p>
-            <a:pPr>
-              <a:spcBef>
-                <a:spcPts val="1200"/>
-              </a:spcBef>
-              <a:spcAft>
-                <a:spcPts val="1200"/>
-              </a:spcAft>
-              <a:defRPr sz="2800">
-                <a:solidFill>
-                  <a:srgbClr val="282828"/>
-                </a:solidFill>
-                <a:latin typeface="Calibri"/>
-              </a:defRPr>
-            </a:pPr>
-          </a:p>
-          <a:p>
-            <a:pPr>
-              <a:spcBef>
-                <a:spcPts val="1200"/>
-              </a:spcBef>
-              <a:spcAft>
-                <a:spcPts val="1200"/>
-              </a:spcAft>
-              <a:defRPr sz="2800">
-                <a:solidFill>
-                  <a:srgbClr val="282828"/>
-                </a:solidFill>
-                <a:latin typeface="Calibri"/>
-              </a:defRPr>
-            </a:pPr>
-            <a:r>
-              <a:t>Dead tests linger. Real gaps go unnoticed.</a:t>
+              <a:t>Dead tests linger, real gaps go unnoticed</a:t>
             </a:r>
           </a:p>
         </p:txBody>
@@ -3380,8 +3348,8 @@
         </p:nvSpPr>
         <p:spPr>
           <a:xfrm>
-            <a:off x="457200" y="457200"/>
-            <a:ext cx="8229600" cy="914400"/>
+            <a:off x="685800" y="457200"/>
+            <a:ext cx="7772400" cy="914400"/>
           </a:xfrm>
           <a:prstGeom prst="rect">
             <a:avLst/>
@@ -3389,7 +3357,7 @@
           <a:noFill/>
         </p:spPr>
         <p:txBody>
-          <a:bodyPr wrap="none">
+          <a:bodyPr wrap="square">
             <a:spAutoFit/>
           </a:bodyPr>
           <a:lstStyle/>
@@ -3397,7 +3365,7 @@
             <a:pPr>
               <a:defRPr sz="5400" b="1">
                 <a:solidFill>
-                  <a:srgbClr val="282828"/>
+                  <a:srgbClr val="009688"/>
                 </a:solidFill>
                 <a:latin typeface="Calibri"/>
               </a:defRPr>
@@ -3416,8 +3384,8 @@
         </p:nvSpPr>
         <p:spPr>
           <a:xfrm>
-            <a:off x="914400" y="1828800"/>
-            <a:ext cx="7315200" cy="4114800"/>
+            <a:off x="1371600" y="1645920"/>
+            <a:ext cx="7315200" cy="4572000"/>
           </a:xfrm>
           <a:prstGeom prst="rect">
             <a:avLst/>
@@ -3439,13 +3407,13 @@
               </a:spcAft>
               <a:defRPr sz="2800">
                 <a:solidFill>
-                  <a:srgbClr val="282828"/>
+                  <a:srgbClr val="1E1E1E"/>
                 </a:solidFill>
                 <a:latin typeface="Calibri"/>
               </a:defRPr>
             </a:pPr>
             <a:r>
-              <a:t>Marrow instruments a single test run.</a:t>
+              <a:t>Instruments a single test run</a:t>
             </a:r>
           </a:p>
           <a:p>
@@ -3458,11 +3426,14 @@
               </a:spcAft>
               <a:defRPr sz="2800">
                 <a:solidFill>
-                  <a:srgbClr val="282828"/>
+                  <a:srgbClr val="1E1E1E"/>
                 </a:solidFill>
                 <a:latin typeface="Calibri"/>
               </a:defRPr>
             </a:pPr>
+            <a:r>
+              <a:t>Produces a test→code coverage map</a:t>
+            </a:r>
           </a:p>
           <a:p>
             <a:pPr>
@@ -3474,48 +3445,13 @@
               </a:spcAft>
               <a:defRPr sz="2800">
                 <a:solidFill>
-                  <a:srgbClr val="282828"/>
+                  <a:srgbClr val="1E1E1E"/>
                 </a:solidFill>
                 <a:latin typeface="Calibri"/>
               </a:defRPr>
             </a:pPr>
             <a:r>
-              <a:t>Produces a test → code coverage map.</a:t>
-            </a:r>
-          </a:p>
-          <a:p>
-            <a:pPr>
-              <a:spcBef>
-                <a:spcPts val="1200"/>
-              </a:spcBef>
-              <a:spcAft>
-                <a:spcPts val="1200"/>
-              </a:spcAft>
-              <a:defRPr sz="2800">
-                <a:solidFill>
-                  <a:srgbClr val="282828"/>
-                </a:solidFill>
-                <a:latin typeface="Calibri"/>
-              </a:defRPr>
-            </a:pPr>
-          </a:p>
-          <a:p>
-            <a:pPr>
-              <a:spcBef>
-                <a:spcPts val="1200"/>
-              </a:spcBef>
-              <a:spcAft>
-                <a:spcPts val="1200"/>
-              </a:spcAft>
-              <a:defRPr sz="2800">
-                <a:solidFill>
-                  <a:srgbClr val="282828"/>
-                </a:solidFill>
-                <a:latin typeface="Calibri"/>
-              </a:defRPr>
-            </a:pPr>
-            <a:r>
-              <a:t>No annotations. No config.</a:t>
+              <a:t>No annotations, no config</a:t>
             </a:r>
           </a:p>
         </p:txBody>
@@ -3554,8 +3490,8 @@
         </p:nvSpPr>
         <p:spPr>
           <a:xfrm>
-            <a:off x="457200" y="457200"/>
-            <a:ext cx="8229600" cy="731520"/>
+            <a:off x="685800" y="457200"/>
+            <a:ext cx="7772400" cy="914400"/>
           </a:xfrm>
           <a:prstGeom prst="rect">
             <a:avLst/>
@@ -3563,7 +3499,7 @@
           <a:noFill/>
         </p:spPr>
         <p:txBody>
-          <a:bodyPr wrap="none">
+          <a:bodyPr wrap="square">
             <a:spAutoFit/>
           </a:bodyPr>
           <a:lstStyle/>
@@ -3571,7 +3507,7 @@
             <a:pPr>
               <a:defRPr sz="5400" b="1">
                 <a:solidFill>
-                  <a:srgbClr val="282828"/>
+                  <a:srgbClr val="009688"/>
                 </a:solidFill>
                 <a:latin typeface="Calibri"/>
               </a:defRPr>
@@ -3590,7 +3526,7 @@
         </p:nvSpPr>
         <p:spPr>
           <a:xfrm>
-            <a:off x="914400" y="1463040"/>
+            <a:off x="1371600" y="1645920"/>
             <a:ext cx="7315200" cy="4572000"/>
           </a:xfrm>
           <a:prstGeom prst="rect">
@@ -3606,109 +3542,58 @@
           <a:p>
             <a:pPr>
               <a:spcBef>
-                <a:spcPts val="1000"/>
+                <a:spcPts val="1200"/>
               </a:spcBef>
               <a:spcAft>
-                <a:spcPts val="1000"/>
+                <a:spcPts val="1200"/>
               </a:spcAft>
-              <a:defRPr sz="2400">
+              <a:defRPr sz="2800">
                 <a:solidFill>
-                  <a:srgbClr val="282828"/>
+                  <a:srgbClr val="1E1E1E"/>
                 </a:solidFill>
                 <a:latin typeface="Calibri"/>
               </a:defRPr>
             </a:pPr>
             <a:r>
-              <a:t>1. Run: marrow watch -- &lt;your test cmd&gt;</a:t>
+              <a:t>Run: marrow watch -- &lt;your test cmd&gt;</a:t>
             </a:r>
           </a:p>
           <a:p>
             <a:pPr>
               <a:spcBef>
-                <a:spcPts val="1000"/>
+                <a:spcPts val="1200"/>
               </a:spcBef>
               <a:spcAft>
-                <a:spcPts val="1000"/>
+                <a:spcPts val="1200"/>
               </a:spcAft>
-              <a:defRPr sz="2400">
+              <a:defRPr sz="2800">
                 <a:solidFill>
-                  <a:srgbClr val="282828"/>
+                  <a:srgbClr val="1E1E1E"/>
                 </a:solidFill>
                 <a:latin typeface="Calibri"/>
               </a:defRPr>
             </a:pPr>
+            <a:r>
+              <a:t>Records which lines each test exercised</a:t>
+            </a:r>
           </a:p>
           <a:p>
             <a:pPr>
               <a:spcBef>
-                <a:spcPts val="1000"/>
+                <a:spcPts val="1200"/>
               </a:spcBef>
               <a:spcAft>
-                <a:spcPts val="1000"/>
+                <a:spcPts val="1200"/>
               </a:spcAft>
-              <a:defRPr sz="2400">
+              <a:defRPr sz="2800">
                 <a:solidFill>
-                  <a:srgbClr val="282828"/>
+                  <a:srgbClr val="1E1E1E"/>
                 </a:solidFill>
                 <a:latin typeface="Calibri"/>
               </a:defRPr>
             </a:pPr>
             <a:r>
-              <a:t>2. Marrow records which lines each test exercised</a:t>
-            </a:r>
-          </a:p>
-          <a:p>
-            <a:pPr>
-              <a:spcBef>
-                <a:spcPts val="1000"/>
-              </a:spcBef>
-              <a:spcAft>
-                <a:spcPts val="1000"/>
-              </a:spcAft>
-              <a:defRPr sz="2400">
-                <a:solidFill>
-                  <a:srgbClr val="282828"/>
-                </a:solidFill>
-                <a:latin typeface="Calibri"/>
-              </a:defRPr>
-            </a:pPr>
-          </a:p>
-          <a:p>
-            <a:pPr>
-              <a:spcBef>
-                <a:spcPts val="1000"/>
-              </a:spcBef>
-              <a:spcAft>
-                <a:spcPts val="1000"/>
-              </a:spcAft>
-              <a:defRPr sz="2400">
-                <a:solidFill>
-                  <a:srgbClr val="282828"/>
-                </a:solidFill>
-                <a:latin typeface="Calibri"/>
-              </a:defRPr>
-            </a:pPr>
-            <a:r>
-              <a:t>3. Emits an interactive map, lists dead tests</a:t>
-            </a:r>
-          </a:p>
-          <a:p>
-            <a:pPr>
-              <a:spcBef>
-                <a:spcPts val="1000"/>
-              </a:spcBef>
-              <a:spcAft>
-                <a:spcPts val="1000"/>
-              </a:spcAft>
-              <a:defRPr sz="2400">
-                <a:solidFill>
-                  <a:srgbClr val="282828"/>
-                </a:solidFill>
-                <a:latin typeface="Calibri"/>
-              </a:defRPr>
-            </a:pPr>
-            <a:r>
-              <a:t>   and untested lines</a:t>
+              <a:t>Emits interactive map + dead tests + untested lines</a:t>
             </a:r>
           </a:p>
         </p:txBody>
@@ -3747,8 +3632,8 @@
         </p:nvSpPr>
         <p:spPr>
           <a:xfrm>
-            <a:off x="457200" y="914400"/>
-            <a:ext cx="8229600" cy="1097280"/>
+            <a:off x="685800" y="457200"/>
+            <a:ext cx="7772400" cy="914400"/>
           </a:xfrm>
           <a:prstGeom prst="rect">
             <a:avLst/>
@@ -3756,15 +3641,15 @@
           <a:noFill/>
         </p:spPr>
         <p:txBody>
-          <a:bodyPr wrap="none">
+          <a:bodyPr wrap="square">
             <a:spAutoFit/>
           </a:bodyPr>
           <a:lstStyle/>
           <a:p>
-            <a:pPr algn="ctr">
+            <a:pPr>
               <a:defRPr sz="5400" b="1">
                 <a:solidFill>
-                  <a:srgbClr val="282828"/>
+                  <a:srgbClr val="009688"/>
                 </a:solidFill>
                 <a:latin typeface="Calibri"/>
               </a:defRPr>
@@ -3783,8 +3668,8 @@
         </p:nvSpPr>
         <p:spPr>
           <a:xfrm>
-            <a:off x="914400" y="2560320"/>
-            <a:ext cx="7315200" cy="1097280"/>
+            <a:off x="1371600" y="1645920"/>
+            <a:ext cx="7315200" cy="4572000"/>
           </a:xfrm>
           <a:prstGeom prst="rect">
             <a:avLst/>
@@ -3792,57 +3677,46 @@
           <a:noFill/>
         </p:spPr>
         <p:txBody>
-          <a:bodyPr wrap="none">
-            <a:spAutoFit/>
-          </a:bodyPr>
-          <a:lstStyle/>
-          <a:p>
-            <a:pPr algn="ctr">
-              <a:defRPr sz="3600" b="1">
-                <a:solidFill>
-                  <a:srgbClr val="007896"/>
-                </a:solidFill>
-                <a:latin typeface="Courier New"/>
-              </a:defRPr>
-            </a:pPr>
-            <a:r>
-              <a:t>pipx install marrow</a:t>
-            </a:r>
-          </a:p>
-        </p:txBody>
-      </p:sp>
-      <p:sp>
-        <p:nvSpPr>
-          <p:cNvPr id="4" name="TextBox 3"/>
-          <p:cNvSpPr txBox="1"/>
-          <p:nvPr/>
-        </p:nvSpPr>
-        <p:spPr>
-          <a:xfrm>
-            <a:off x="914400" y="4114800"/>
-            <a:ext cx="7315200" cy="1828800"/>
-          </a:xfrm>
-          <a:prstGeom prst="rect">
-            <a:avLst/>
-          </a:prstGeom>
-          <a:noFill/>
-        </p:spPr>
-        <p:txBody>
           <a:bodyPr wrap="square">
             <a:spAutoFit/>
           </a:bodyPr>
           <a:lstStyle/>
           <a:p>
-            <a:pPr algn="ctr">
+            <a:pPr>
+              <a:spcBef>
+                <a:spcPts val="1200"/>
+              </a:spcBef>
+              <a:spcAft>
+                <a:spcPts val="1200"/>
+              </a:spcAft>
               <a:defRPr sz="2800">
                 <a:solidFill>
-                  <a:srgbClr val="646464"/>
+                  <a:srgbClr val="1E1E1E"/>
                 </a:solidFill>
                 <a:latin typeface="Calibri"/>
               </a:defRPr>
             </a:pPr>
             <a:r>
-              <a:t>Works with pytest, Jest, go test.</a:t>
+              <a:t>pipx install marrow</a:t>
+            </a:r>
+          </a:p>
+          <a:p>
+            <a:pPr>
+              <a:spcBef>
+                <a:spcPts val="1200"/>
+              </a:spcBef>
+              <a:spcAft>
+                <a:spcPts val="1200"/>
+              </a:spcAft>
+              <a:defRPr sz="2800">
+                <a:solidFill>
+                  <a:srgbClr val="1E1E1E"/>
+                </a:solidFill>
+                <a:latin typeface="Calibri"/>
+              </a:defRPr>
+            </a:pPr>
+            <a:r>
+              <a:t>Works with pytest, Jest, go test</a:t>
             </a:r>
           </a:p>
         </p:txBody>

</xml_diff>